<commit_message>
Mise à jour du 28 octobre : PDF joint au dossier (une version), PDF du plan, écran allégé, Transmis aux RH, dates sans fr-CA ; documents à jour
Co-Authored-By: Claude Opus 5.5 <noreply@anthropic.com>
Claude-Session: https://claude.ai/code/session_01FRdAzq8p3F9gJJe5MA3G79
</commit_message>
<xml_diff>
--- a/powerapps/presentation/Presentation-Appreciation-contribution.pptx
+++ b/powerapps/presentation/Presentation-Appreciation-contribution.pptx
@@ -124,19 +124,19 @@
   <p:extLst>
     <p:ext uri="{521415D9-36F7-43E2-AB2F-B90AF26B5E84}">
       <p14:sectionLst xmlns:p14="http://schemas.microsoft.com/office/powerpoint/2010/main">
-        <p14:section name="Introduction" id="{e3a63558-b9e3-78f1-3f5c-a45705f97831}">
+        <p14:section name="Introduction" id="{2df7a247-2392-0078-a545-b6fa6599c1e7}">
           <p14:sldIdLst>
             <p14:sldId id="256"/>
             <p14:sldId id="257"/>
           </p14:sldIdLst>
         </p14:section>
-        <p14:section name="Point de départ" id="{d547e533-16b1-080a-8170-89885127ffae}">
+        <p14:section name="Point de départ" id="{3b65a3c3-321d-5adf-ffa8-0add9783313c}">
           <p14:sldIdLst>
             <p14:sldId id="258"/>
             <p14:sldId id="259"/>
           </p14:sldIdLst>
         </p14:section>
-        <p14:section name="Démarche" id="{c6d5dd76-0d7a-8210-7722-cf3ae948b836}">
+        <p14:section name="Démarche" id="{c7c7de75-78b0-e191-7adf-ea6934116f68}">
           <p14:sldIdLst>
             <p14:sldId id="260"/>
             <p14:sldId id="261"/>
@@ -144,21 +144,21 @@
             <p14:sldId id="263"/>
           </p14:sldIdLst>
         </p14:section>
-        <p14:section name="Solution" id="{5ddfad7d-ad47-095e-e28b-af4c83e7b52d}">
+        <p14:section name="Solution" id="{e9731beb-d09c-f318-8074-87f71bf860c5}">
           <p14:sldIdLst>
             <p14:sldId id="264"/>
             <p14:sldId id="265"/>
             <p14:sldId id="266"/>
           </p14:sldIdLst>
         </p14:section>
-        <p14:section name="Tests" id="{8885b542-d0d8-d1b4-c6f0-b8f504635bf6}">
+        <p14:section name="Tests" id="{12651916-86fb-8669-c587-683931327f8e}">
           <p14:sldIdLst>
             <p14:sldId id="267"/>
             <p14:sldId id="268"/>
             <p14:sldId id="269"/>
           </p14:sldIdLst>
         </p14:section>
-        <p14:section name="Résultat" id="{6ff8054a-5b36-52a4-7ea9-0765f3e2d5ea}">
+        <p14:section name="Résultat" id="{24dcd5a9-a8cd-ca42-a9c5-1fca96f2bd7d}">
           <p14:sldIdLst>
             <p14:sldId id="270"/>
             <p14:sldId id="271"/>
@@ -3470,7 +3470,7 @@
                   <a:srgbClr val="FFD98A"/>
                 </a:solidFill>
               </a:rPr>
-              <a:t>17</a:t>
+              <a:t>23</a:t>
             </a:r>
             <a:endParaRPr lang="en-US" sz="4400" dirty="0"/>
           </a:p>
@@ -4343,7 +4343,7 @@
                   <a:schemeClr val="tx1"/>
                 </a:solidFill>
               </a:rPr>
-              <a:t>Nouveau flux : PDF complet de plusieurs pages, déposé dans une bibliothèque protégée.</a:t>
+              <a:t>PDF complet et PDF du plan, joints au dossier (une seule version, mêmes accès).</a:t>
             </a:r>
             <a:endParaRPr lang="en-US" sz="1300" dirty="0"/>
           </a:p>
@@ -4590,7 +4590,7 @@
                   <a:schemeClr val="tx1"/>
                 </a:solidFill>
               </a:rPr>
-              <a:t>Les PDF sont rangés dans une bibliothèque fermée</a:t>
+              <a:t>Le PDF est joint au dossier, avec les mêmes accès</a:t>
             </a:r>
             <a:endParaRPr lang="en-US" sz="1400" dirty="0"/>
           </a:p>
@@ -5068,7 +5068,7 @@
                   <a:schemeClr val="tx1"/>
                 </a:solidFill>
               </a:rPr>
-              <a:t>Formulaire complet, 3 types de poste, barre d'étapes, synthèse, plan, PDF</a:t>
+              <a:t>Formulaire complet, 3 types de poste, barre d'étapes, plan, PDF joint au dossier</a:t>
             </a:r>
             <a:endParaRPr lang="en-US" sz="1300" dirty="0"/>
           </a:p>
@@ -7368,7 +7368,7 @@
                   <a:schemeClr val="tx1"/>
                 </a:solidFill>
               </a:rPr>
-              <a:t>Signatures, moyennes, synthèse et transmission à la paie faites à la main.</a:t>
+              <a:t>Signatures, moyennes, synthèse et transmission aux RH faites à la main.</a:t>
             </a:r>
             <a:endParaRPr lang="en-US" sz="1400" dirty="0"/>
           </a:p>
@@ -7633,7 +7633,7 @@
                   <a:schemeClr val="tx1"/>
                 </a:solidFill>
               </a:rPr>
-              <a:t>Transmission de l'évaluation globale à la paie</a:t>
+              <a:t>Transmission de l'évaluation globale aux RH</a:t>
             </a:r>
             <a:endParaRPr lang="en-US" sz="1400" dirty="0"/>
           </a:p>

</xml_diff>

<commit_message>
Retrait des onglets Synthèse et Plan de développement et du PDF du plan ; documents à jour
Co-Authored-By: Claude Opus 5.5 <noreply@anthropic.com>
Claude-Session: https://claude.ai/code/session_01FRdAzq8p3F9gJJe5MA3G79
</commit_message>
<xml_diff>
--- a/powerapps/presentation/Presentation-Appreciation-contribution.pptx
+++ b/powerapps/presentation/Presentation-Appreciation-contribution.pptx
@@ -124,19 +124,19 @@
   <p:extLst>
     <p:ext uri="{521415D9-36F7-43E2-AB2F-B90AF26B5E84}">
       <p14:sectionLst xmlns:p14="http://schemas.microsoft.com/office/powerpoint/2010/main">
-        <p14:section name="Introduction" id="{2df7a247-2392-0078-a545-b6fa6599c1e7}">
+        <p14:section name="Introduction" id="{2a2215ec-66fb-5371-a88f-0bc3cfda5cba}">
           <p14:sldIdLst>
             <p14:sldId id="256"/>
             <p14:sldId id="257"/>
           </p14:sldIdLst>
         </p14:section>
-        <p14:section name="Point de départ" id="{3b65a3c3-321d-5adf-ffa8-0add9783313c}">
+        <p14:section name="Point de départ" id="{d28fae23-046a-9e8f-6b99-4a4a4bbc80cd}">
           <p14:sldIdLst>
             <p14:sldId id="258"/>
             <p14:sldId id="259"/>
           </p14:sldIdLst>
         </p14:section>
-        <p14:section name="Démarche" id="{c7c7de75-78b0-e191-7adf-ea6934116f68}">
+        <p14:section name="Démarche" id="{ebbeef4a-b98b-d84c-70d0-76d0334e6252}">
           <p14:sldIdLst>
             <p14:sldId id="260"/>
             <p14:sldId id="261"/>
@@ -144,21 +144,21 @@
             <p14:sldId id="263"/>
           </p14:sldIdLst>
         </p14:section>
-        <p14:section name="Solution" id="{e9731beb-d09c-f318-8074-87f71bf860c5}">
+        <p14:section name="Solution" id="{9a351ad8-2de4-b657-b076-d3dcb5718e5e}">
           <p14:sldIdLst>
             <p14:sldId id="264"/>
             <p14:sldId id="265"/>
             <p14:sldId id="266"/>
           </p14:sldIdLst>
         </p14:section>
-        <p14:section name="Tests" id="{12651916-86fb-8669-c587-683931327f8e}">
+        <p14:section name="Tests" id="{75eae962-f2c6-c7cd-dbd5-5ad79b2e3eb3}">
           <p14:sldIdLst>
             <p14:sldId id="267"/>
             <p14:sldId id="268"/>
             <p14:sldId id="269"/>
           </p14:sldIdLst>
         </p14:section>
-        <p14:section name="Résultat" id="{24dcd5a9-a8cd-ca42-a9c5-1fca96f2bd7d}">
+        <p14:section name="Résultat" id="{611e9eb9-db8b-49ef-f16e-e2eab027708a}">
           <p14:sldIdLst>
             <p14:sldId id="270"/>
             <p14:sldId id="271"/>
@@ -4343,7 +4343,7 @@
                   <a:schemeClr val="tx1"/>
                 </a:solidFill>
               </a:rPr>
-              <a:t>PDF complet et PDF du plan, joints au dossier (une seule version, mêmes accès).</a:t>
+              <a:t>PDF complet joint au dossier (une seule version, mêmes accès) ; écran allégé.</a:t>
             </a:r>
             <a:endParaRPr lang="en-US" sz="1300" dirty="0"/>
           </a:p>
@@ -5068,7 +5068,7 @@
                   <a:schemeClr val="tx1"/>
                 </a:solidFill>
               </a:rPr>
-              <a:t>Formulaire complet, 3 types de poste, barre d'étapes, plan, PDF joint au dossier</a:t>
+              <a:t>Formulaire complet, 3 types de poste, barre d'étapes, PDF joint au dossier</a:t>
             </a:r>
             <a:endParaRPr lang="en-US" sz="1300" dirty="0"/>
           </a:p>

</xml_diff>

<commit_message>
Appréciation de la contribution : version finale (28 octobre 2026)
Tous les documents, visuels, Excel et présentation portent la mention
version finale ; ajout d'une archive ZIP regroupant les livrables.

Co-Authored-By: Claude Opus 5.5 <noreply@anthropic.com>
Claude-Session: https://claude.ai/code/session_01FRdAzq8p3F9gJJe5MA3G79
</commit_message>
<xml_diff>
--- a/powerapps/presentation/Presentation-Appreciation-contribution.pptx
+++ b/powerapps/presentation/Presentation-Appreciation-contribution.pptx
@@ -124,19 +124,19 @@
   <p:extLst>
     <p:ext uri="{521415D9-36F7-43E2-AB2F-B90AF26B5E84}">
       <p14:sectionLst xmlns:p14="http://schemas.microsoft.com/office/powerpoint/2010/main">
-        <p14:section name="Introduction" id="{2a2215ec-66fb-5371-a88f-0bc3cfda5cba}">
+        <p14:section name="Introduction" id="{c4cb5ccc-5b68-e6ec-2670-41471f08f910}">
           <p14:sldIdLst>
             <p14:sldId id="256"/>
             <p14:sldId id="257"/>
           </p14:sldIdLst>
         </p14:section>
-        <p14:section name="Point de départ" id="{d28fae23-046a-9e8f-6b99-4a4a4bbc80cd}">
+        <p14:section name="Point de départ" id="{11d25bf3-fd68-aa49-9741-4607cbca89a6}">
           <p14:sldIdLst>
             <p14:sldId id="258"/>
             <p14:sldId id="259"/>
           </p14:sldIdLst>
         </p14:section>
-        <p14:section name="Démarche" id="{ebbeef4a-b98b-d84c-70d0-76d0334e6252}">
+        <p14:section name="Démarche" id="{8f9c72b1-e7e5-0763-e0a8-135d59577926}">
           <p14:sldIdLst>
             <p14:sldId id="260"/>
             <p14:sldId id="261"/>
@@ -144,21 +144,21 @@
             <p14:sldId id="263"/>
           </p14:sldIdLst>
         </p14:section>
-        <p14:section name="Solution" id="{9a351ad8-2de4-b657-b076-d3dcb5718e5e}">
+        <p14:section name="Solution" id="{19331008-7f4a-228e-0e49-f850c6d29814}">
           <p14:sldIdLst>
             <p14:sldId id="264"/>
             <p14:sldId id="265"/>
             <p14:sldId id="266"/>
           </p14:sldIdLst>
         </p14:section>
-        <p14:section name="Tests" id="{75eae962-f2c6-c7cd-dbd5-5ad79b2e3eb3}">
+        <p14:section name="Tests" id="{8cf02572-fe16-bfd6-dc69-5b3dd2a02d92}">
           <p14:sldIdLst>
             <p14:sldId id="267"/>
             <p14:sldId id="268"/>
             <p14:sldId id="269"/>
           </p14:sldIdLst>
         </p14:section>
-        <p14:section name="Résultat" id="{611e9eb9-db8b-49ef-f16e-e2eab027708a}">
+        <p14:section name="Résultat" id="{c6caeec3-8a47-c61b-8b10-1bef03f1653f}">
           <p14:sldIdLst>
             <p14:sldId id="270"/>
             <p14:sldId id="271"/>
@@ -2981,7 +2981,21 @@
                   <a:srgbClr val="D9DEE8"/>
                 </a:solidFill>
               </a:rPr>
-              <a:t>Présenté par Annie Audet, conseillère en ressources humaines (RH-SST) — octobre 2026</a:t>
+              <a:t>Présenté par Annie Audet, conseillère en ressources humaines (RH-SST)</a:t>
+            </a:r>
+            <a:endParaRPr lang="en-US" sz="1800" dirty="0"/>
+          </a:p>
+          <a:p>
+            <a:pPr indent="0" marL="0">
+              <a:buNone/>
+            </a:pPr>
+            <a:r>
+              <a:rPr lang="en-US" sz="1800" dirty="0">
+                <a:solidFill>
+                  <a:srgbClr val="D9DEE8"/>
+                </a:solidFill>
+              </a:rPr>
+              <a:t>Version finale — 28 octobre 2026</a:t>
             </a:r>
             <a:endParaRPr lang="en-US" sz="1800" dirty="0"/>
           </a:p>

</xml_diff>